<commit_message>
saved the edits in the slides
</commit_message>
<xml_diff>
--- a/slides_editable.pptx
+++ b/slides_editable.pptx
@@ -3246,7 +3246,7 @@
         </p:nvSpPr>
         <p:spPr>
           <a:xfrm>
-            <a:off x="3583463" y="4419026"/>
+            <a:off x="3583463" y="4430931"/>
             <a:ext cx="935235" cy="333375"/>
           </a:xfrm>
           <a:prstGeom prst="rect">
@@ -3282,7 +3282,7 @@
         </p:nvSpPr>
         <p:spPr>
           <a:xfrm>
-            <a:off x="4652876" y="4431082"/>
+            <a:off x="4652876" y="4433981"/>
             <a:ext cx="1178867" cy="333375"/>
           </a:xfrm>
           <a:prstGeom prst="rect">
@@ -3340,6 +3340,7 @@
               </a:defRPr>
             </a:pPr>
             <a:r>
+              <a:rPr dirty="0"/>
               <a:t>HMAC-SHA256</a:t>
             </a:r>
           </a:p>
@@ -3389,8 +3390,8 @@
         </p:nvSpPr>
         <p:spPr>
           <a:xfrm>
-            <a:off x="3141420" y="5410497"/>
-            <a:ext cx="5424338" cy="338137"/>
+            <a:off x="3012486" y="5410464"/>
+            <a:ext cx="5638513" cy="215444"/>
           </a:xfrm>
           <a:prstGeom prst="rect">
             <a:avLst/>
@@ -3411,7 +3412,24 @@
               </a:defRPr>
             </a:pPr>
             <a:r>
-              <a:t>Presented by: Waqas Ul Hasan (FA23-BCS-167) &amp; Qurat Ul ain (FA23-BCS-195)</a:t>
+              <a:rPr sz="1400" dirty="0"/>
+              <a:t>Presented by: Waqas Ul Hasan (FA23-BCS-167) &amp; </a:t>
+            </a:r>
+            <a:r>
+              <a:rPr sz="1400" dirty="0" err="1"/>
+              <a:t>Qurat</a:t>
+            </a:r>
+            <a:r>
+              <a:rPr sz="1400" dirty="0"/>
+              <a:t> Ul </a:t>
+            </a:r>
+            <a:r>
+              <a:rPr sz="1400" dirty="0" err="1"/>
+              <a:t>ain</a:t>
+            </a:r>
+            <a:r>
+              <a:rPr sz="1400" dirty="0"/>
+              <a:t> (FA23-BCS-195)</a:t>
             </a:r>
           </a:p>
         </p:txBody>
@@ -4634,7 +4652,7 @@
         <p:spPr>
           <a:xfrm>
             <a:off x="1038224" y="5107632"/>
-            <a:ext cx="10115549" cy="354210"/>
+            <a:ext cx="10115549" cy="215444"/>
           </a:xfrm>
           <a:prstGeom prst="rect">
             <a:avLst/>
@@ -4655,7 +4673,7 @@
               </a:defRPr>
             </a:pPr>
             <a:r>
-              <a:rPr dirty="0"/>
+              <a:rPr sz="1400" dirty="0"/>
               <a:t>Solution: Combine symmetric speed with asymmetric security — Hybrid Cryptography</a:t>
             </a:r>
           </a:p>

</xml_diff>